<commit_message>
Prepare the deck for presentation to Automatum
Strips the working-draft voice from the slide copy while keeping every
open question as the agenda it is. OBP's negotiating stance comes off
the partner economics band, the row aimed at Automatum reads "needed
first" rather than BLOCKING, and the self-critical notes on the
scoreboard, sequence and rename-cascade slides are rephrased neutrally.
The title slide carries the revision date.

The decision slide is rebuilt to the current state: retainer outcomes
are marked set for all three, staffing and bands are the one remaining
OBP item, the back-to-back turnarounds are framed as needed before any
turnaround is published, and the CPPO boundary joins the ask. The spec's
decision-slide table is synced to match.

Tone, numeric, wording, traceability and commit-column audits all pass;
the file validates.

Co-Authored-By: Claude Fable 5.1 <noreply@anthropic.com>
Claude-Session: https://claude.ai/code/session_01CBKHd7JVCEZji4PgXYk58r
</commit_message>
<xml_diff>
--- a/docs/deck/BOX_Solutions_Revised.pptx
+++ b/docs/deck/BOX_Solutions_Revised.pptx
@@ -3563,7 +3563,7 @@
                 <a:ea typeface="Segoe UI Semilight" pitchFamily="34" charset="-122"/>
                 <a:cs typeface="Segoe UI Semilight" pitchFamily="34" charset="-120"/>
               </a:rPr>
-              <a:t>Bracketed figures are unset. No bracket reaches a customer artifact.</a:t>
+              <a:t>Bracketed items are open for decision. None reaches a customer artifact.</a:t>
             </a:r>
             <a:endParaRPr lang="en-US" sz="850" dirty="0"/>
           </a:p>
@@ -3602,7 +3602,7 @@
                 <a:ea typeface="Segoe UI" pitchFamily="34" charset="-122"/>
                 <a:cs typeface="Segoe UI" pitchFamily="34" charset="-120"/>
               </a:rPr>
-              <a:t>BOX Solutions   ·   revised</a:t>
+              <a:t>BOX Solutions   ·   revised 2026-09-02</a:t>
             </a:r>
             <a:endParaRPr lang="en-US" sz="900" dirty="0"/>
           </a:p>
@@ -11548,7 +11548,7 @@
                 <a:ea typeface="Segoe UI Semilight" pitchFamily="34" charset="-122"/>
                 <a:cs typeface="Segoe UI Semilight" pitchFamily="34" charset="-120"/>
               </a:rPr>
-              <a:t>    Both lines above appear on every customer overview and deck, or the commit column silently acquires a number nobody set.</a:t>
+              <a:t>    Both lines above appear on every customer overview and deck, so no target is ever mistaken for a commitment.</a:t>
             </a:r>
             <a:endParaRPr lang="en-US" sz="1050" dirty="0"/>
           </a:p>
@@ -15590,7 +15590,7 @@
                 <a:ea typeface="Segoe UI Semilight" pitchFamily="34" charset="-122"/>
                 <a:cs typeface="Segoe UI Semilight" pitchFamily="34" charset="-120"/>
               </a:rPr>
-              <a:t>Automatum · BLOCKING</a:t>
+              <a:t>Automatum · needed first</a:t>
             </a:r>
             <a:endParaRPr lang="en-US" sz="850" dirty="0"/>
           </a:p>
@@ -15899,7 +15899,7 @@
                 <a:ea typeface="Segoe UI Semilight" pitchFamily="34" charset="-122"/>
                 <a:cs typeface="Segoe UI Semilight" pitchFamily="34" charset="-120"/>
               </a:rPr>
-              <a:t>    The $10,000 fee and the ladder cannot be validated until OBP knows its share. A split below OBP’s walk-away means the prices are wrong, not the split.</a:t>
+              <a:t>    The fee and the ladder are only validated once the split is known — so these terms come before any repricing.</a:t>
             </a:r>
             <a:endParaRPr lang="en-US" sz="1050" dirty="0"/>
           </a:p>
@@ -18440,7 +18440,7 @@
                 <a:ea typeface="Segoe UI Semilight" pitchFamily="34" charset="-122"/>
                 <a:cs typeface="Segoe UI Semilight" pitchFamily="34" charset="-120"/>
               </a:rPr>
-              <a:t>The whole recommendation is contingent on the 12-month listing clock running per Solution ID from entry. If it runs programme-level, sequencing burns the clock rather than staggering it, and this slide is wrong.</a:t>
+              <a:t>The whole recommendation is contingent on the 12-month listing clock running per Solution ID from entry. If it runs programme-level, sequencing burns the clock rather than staggering it, and the sequence changes.</a:t>
             </a:r>
             <a:endParaRPr lang="en-US" sz="850" dirty="0"/>
           </a:p>
@@ -18750,8 +18750,8 @@
         </p:nvSpPr>
         <p:spPr>
           <a:xfrm>
-            <a:off x="566420" y="2216150"/>
-            <a:ext cx="11055350" cy="292100"/>
+            <a:off x="566420" y="2165350"/>
+            <a:ext cx="11055350" cy="266700"/>
           </a:xfrm>
           <a:prstGeom prst="rect">
             <a:avLst/>
@@ -18770,7 +18770,7 @@
         </p:nvSpPr>
         <p:spPr>
           <a:xfrm>
-            <a:off x="749300" y="2286000"/>
+            <a:off x="749300" y="2235200"/>
             <a:ext cx="4191000" cy="203200"/>
           </a:xfrm>
           <a:prstGeom prst="rect">
@@ -18787,7 +18787,7 @@
               <a:buNone/>
             </a:pPr>
             <a:r>
-              <a:rPr lang="en-US" sz="950" b="1" dirty="0">
+              <a:rPr lang="en-US" sz="900" b="1" dirty="0">
                 <a:solidFill>
                   <a:srgbClr val="FFFFFF"/>
                 </a:solidFill>
@@ -18797,7 +18797,7 @@
               </a:rPr>
               <a:t>Entry condition or item</a:t>
             </a:r>
-            <a:endParaRPr lang="en-US" sz="950" dirty="0"/>
+            <a:endParaRPr lang="en-US" sz="900" dirty="0"/>
           </a:p>
         </p:txBody>
       </p:sp>
@@ -18809,7 +18809,7 @@
         </p:nvSpPr>
         <p:spPr>
           <a:xfrm>
-            <a:off x="5143500" y="2286000"/>
+            <a:off x="5143500" y="2235200"/>
             <a:ext cx="1905000" cy="203200"/>
           </a:xfrm>
           <a:prstGeom prst="rect">
@@ -18826,7 +18826,7 @@
               <a:buNone/>
             </a:pPr>
             <a:r>
-              <a:rPr lang="en-US" sz="950" b="1" dirty="0">
+              <a:rPr lang="en-US" sz="900" b="1" dirty="0">
                 <a:solidFill>
                   <a:srgbClr val="FFFFFF"/>
                 </a:solidFill>
@@ -18836,7 +18836,7 @@
               </a:rPr>
               <a:t>Owner</a:t>
             </a:r>
-            <a:endParaRPr lang="en-US" sz="950" dirty="0"/>
+            <a:endParaRPr lang="en-US" sz="900" dirty="0"/>
           </a:p>
         </p:txBody>
       </p:sp>
@@ -18848,7 +18848,7 @@
         </p:nvSpPr>
         <p:spPr>
           <a:xfrm>
-            <a:off x="7366000" y="2286000"/>
+            <a:off x="7366000" y="2235200"/>
             <a:ext cx="2895600" cy="203200"/>
           </a:xfrm>
           <a:prstGeom prst="rect">
@@ -18865,7 +18865,7 @@
               <a:buNone/>
             </a:pPr>
             <a:r>
-              <a:rPr lang="en-US" sz="950" b="1" dirty="0">
+              <a:rPr lang="en-US" sz="900" b="1" dirty="0">
                 <a:solidFill>
                   <a:srgbClr val="FFFFFF"/>
                 </a:solidFill>
@@ -18875,7 +18875,7 @@
               </a:rPr>
               <a:t>Standing</a:t>
             </a:r>
-            <a:endParaRPr lang="en-US" sz="950" dirty="0"/>
+            <a:endParaRPr lang="en-US" sz="900" dirty="0"/>
           </a:p>
         </p:txBody>
       </p:sp>
@@ -18887,8 +18887,8 @@
         </p:nvSpPr>
         <p:spPr>
           <a:xfrm>
-            <a:off x="566420" y="2851150"/>
-            <a:ext cx="11055350" cy="292100"/>
+            <a:off x="566420" y="2749550"/>
+            <a:ext cx="11055350" cy="266700"/>
           </a:xfrm>
           <a:prstGeom prst="rect">
             <a:avLst/>
@@ -18907,8 +18907,8 @@
         </p:nvSpPr>
         <p:spPr>
           <a:xfrm>
-            <a:off x="566420" y="3435350"/>
-            <a:ext cx="11055350" cy="292100"/>
+            <a:off x="566420" y="3282950"/>
+            <a:ext cx="11055350" cy="266700"/>
           </a:xfrm>
           <a:prstGeom prst="rect">
             <a:avLst/>
@@ -18927,8 +18927,8 @@
         </p:nvSpPr>
         <p:spPr>
           <a:xfrm>
-            <a:off x="566420" y="4019550"/>
-            <a:ext cx="11055350" cy="292100"/>
+            <a:off x="566420" y="3816350"/>
+            <a:ext cx="11055350" cy="266700"/>
           </a:xfrm>
           <a:prstGeom prst="rect">
             <a:avLst/>
@@ -18947,8 +18947,8 @@
         </p:nvSpPr>
         <p:spPr>
           <a:xfrm>
-            <a:off x="566420" y="4603750"/>
-            <a:ext cx="11055350" cy="292100"/>
+            <a:off x="566420" y="4349750"/>
+            <a:ext cx="11055350" cy="266700"/>
           </a:xfrm>
           <a:prstGeom prst="rect">
             <a:avLst/>
@@ -18961,30 +18961,50 @@
       </p:sp>
       <p:sp>
         <p:nvSpPr>
-          <p:cNvPr id="17" name="Text 13"/>
-          <p:cNvSpPr txBox="1"/>
-          <p:nvPr/>
-        </p:nvSpPr>
-        <p:spPr>
-          <a:xfrm>
-            <a:off x="749300" y="2628900"/>
-            <a:ext cx="4191000" cy="292100"/>
-          </a:xfrm>
-          <a:prstGeom prst="rect">
-            <a:avLst/>
-          </a:prstGeom>
-          <a:noFill/>
-          <a:ln/>
-        </p:spPr>
-        <p:txBody>
-          <a:bodyPr wrap="square" lIns="0" tIns="0" rIns="0" bIns="0" rtlCol="0" anchor="t"/>
-          <a:lstStyle/>
-          <a:p>
-            <a:pPr indent="0" marL="0">
-              <a:buNone/>
-            </a:pPr>
-            <a:r>
-              <a:rPr lang="en-US" sz="950" b="1" dirty="0">
+          <p:cNvPr id="17" name="Shape 13"/>
+          <p:cNvSpPr/>
+          <p:nvPr/>
+        </p:nvSpPr>
+        <p:spPr>
+          <a:xfrm>
+            <a:off x="566420" y="4883150"/>
+            <a:ext cx="11055350" cy="266700"/>
+          </a:xfrm>
+          <a:prstGeom prst="rect">
+            <a:avLst/>
+          </a:prstGeom>
+          <a:solidFill>
+            <a:srgbClr val="F5F8FC"/>
+          </a:solidFill>
+          <a:ln/>
+        </p:spPr>
+      </p:sp>
+      <p:sp>
+        <p:nvSpPr>
+          <p:cNvPr id="18" name="Text 14"/>
+          <p:cNvSpPr txBox="1"/>
+          <p:nvPr/>
+        </p:nvSpPr>
+        <p:spPr>
+          <a:xfrm>
+            <a:off x="749300" y="2552700"/>
+            <a:ext cx="4191000" cy="266700"/>
+          </a:xfrm>
+          <a:prstGeom prst="rect">
+            <a:avLst/>
+          </a:prstGeom>
+          <a:noFill/>
+          <a:ln/>
+        </p:spPr>
+        <p:txBody>
+          <a:bodyPr wrap="square" lIns="0" tIns="0" rIns="0" bIns="0" rtlCol="0" anchor="t"/>
+          <a:lstStyle/>
+          <a:p>
+            <a:pPr indent="0" marL="0">
+              <a:buNone/>
+            </a:pPr>
+            <a:r>
+              <a:rPr lang="en-US" sz="900" b="1" dirty="0">
                 <a:solidFill>
                   <a:srgbClr val="15224B"/>
                 </a:solidFill>
@@ -18994,36 +19014,36 @@
               </a:rPr>
               <a:t>Validated or Differentiated held by the lead partner</a:t>
             </a:r>
-            <a:endParaRPr lang="en-US" sz="950" dirty="0"/>
-          </a:p>
-        </p:txBody>
-      </p:sp>
-      <p:sp>
-        <p:nvSpPr>
-          <p:cNvPr id="18" name="Text 14"/>
-          <p:cNvSpPr txBox="1"/>
-          <p:nvPr/>
-        </p:nvSpPr>
-        <p:spPr>
-          <a:xfrm>
-            <a:off x="5143500" y="2628900"/>
-            <a:ext cx="1905000" cy="292100"/>
-          </a:xfrm>
-          <a:prstGeom prst="rect">
-            <a:avLst/>
-          </a:prstGeom>
-          <a:noFill/>
-          <a:ln/>
-        </p:spPr>
-        <p:txBody>
-          <a:bodyPr wrap="square" lIns="0" tIns="0" rIns="0" bIns="0" rtlCol="0" anchor="t"/>
-          <a:lstStyle/>
-          <a:p>
-            <a:pPr indent="0" marL="0">
-              <a:buNone/>
-            </a:pPr>
-            <a:r>
-              <a:rPr lang="en-US" sz="950" dirty="0">
+            <a:endParaRPr lang="en-US" sz="900" dirty="0"/>
+          </a:p>
+        </p:txBody>
+      </p:sp>
+      <p:sp>
+        <p:nvSpPr>
+          <p:cNvPr id="19" name="Text 15"/>
+          <p:cNvSpPr txBox="1"/>
+          <p:nvPr/>
+        </p:nvSpPr>
+        <p:spPr>
+          <a:xfrm>
+            <a:off x="5143500" y="2552700"/>
+            <a:ext cx="1905000" cy="266700"/>
+          </a:xfrm>
+          <a:prstGeom prst="rect">
+            <a:avLst/>
+          </a:prstGeom>
+          <a:noFill/>
+          <a:ln/>
+        </p:spPr>
+        <p:txBody>
+          <a:bodyPr wrap="square" lIns="0" tIns="0" rIns="0" bIns="0" rtlCol="0" anchor="t"/>
+          <a:lstStyle/>
+          <a:p>
+            <a:pPr indent="0" marL="0">
+              <a:buNone/>
+            </a:pPr>
+            <a:r>
+              <a:rPr lang="en-US" sz="900" dirty="0">
                 <a:solidFill>
                   <a:srgbClr val="5B6378"/>
                 </a:solidFill>
@@ -19033,36 +19053,36 @@
               </a:rPr>
               <a:t>Automatum</a:t>
             </a:r>
-            <a:endParaRPr lang="en-US" sz="950" dirty="0"/>
-          </a:p>
-        </p:txBody>
-      </p:sp>
-      <p:sp>
-        <p:nvSpPr>
-          <p:cNvPr id="19" name="Text 15"/>
-          <p:cNvSpPr txBox="1"/>
-          <p:nvPr/>
-        </p:nvSpPr>
-        <p:spPr>
-          <a:xfrm>
-            <a:off x="7366000" y="2628900"/>
-            <a:ext cx="2895600" cy="292100"/>
-          </a:xfrm>
-          <a:prstGeom prst="rect">
-            <a:avLst/>
-          </a:prstGeom>
-          <a:noFill/>
-          <a:ln/>
-        </p:spPr>
-        <p:txBody>
-          <a:bodyPr wrap="square" lIns="0" tIns="0" rIns="0" bIns="0" rtlCol="0" anchor="t"/>
-          <a:lstStyle/>
-          <a:p>
-            <a:pPr indent="0" marL="0">
-              <a:buNone/>
-            </a:pPr>
-            <a:r>
-              <a:rPr lang="en-US" sz="950" dirty="0">
+            <a:endParaRPr lang="en-US" sz="900" dirty="0"/>
+          </a:p>
+        </p:txBody>
+      </p:sp>
+      <p:sp>
+        <p:nvSpPr>
+          <p:cNvPr id="20" name="Text 16"/>
+          <p:cNvSpPr txBox="1"/>
+          <p:nvPr/>
+        </p:nvSpPr>
+        <p:spPr>
+          <a:xfrm>
+            <a:off x="7366000" y="2552700"/>
+            <a:ext cx="2895600" cy="266700"/>
+          </a:xfrm>
+          <a:prstGeom prst="rect">
+            <a:avLst/>
+          </a:prstGeom>
+          <a:noFill/>
+          <a:ln/>
+        </p:spPr>
+        <p:txBody>
+          <a:bodyPr wrap="square" lIns="0" tIns="0" rIns="0" bIns="0" rtlCol="0" anchor="t"/>
+          <a:lstStyle/>
+          <a:p>
+            <a:pPr indent="0" marL="0">
+              <a:buNone/>
+            </a:pPr>
+            <a:r>
+              <a:rPr lang="en-US" sz="900" dirty="0">
                 <a:solidFill>
                   <a:srgbClr val="5B6378"/>
                 </a:solidFill>
@@ -19070,38 +19090,38 @@
                 <a:ea typeface="Segoe UI Semilight" pitchFamily="34" charset="-122"/>
                 <a:cs typeface="Segoe UI Semilight" pitchFamily="34" charset="-120"/>
               </a:rPr>
-              <a:t>Stated by Automatum (Aein, email) — evidence to attach</a:t>
-            </a:r>
-            <a:endParaRPr lang="en-US" sz="950" dirty="0"/>
-          </a:p>
-        </p:txBody>
-      </p:sp>
-      <p:sp>
-        <p:nvSpPr>
-          <p:cNvPr id="20" name="Text 16"/>
-          <p:cNvSpPr txBox="1"/>
-          <p:nvPr/>
-        </p:nvSpPr>
-        <p:spPr>
-          <a:xfrm>
-            <a:off x="749300" y="2921000"/>
-            <a:ext cx="4191000" cy="292100"/>
-          </a:xfrm>
-          <a:prstGeom prst="rect">
-            <a:avLst/>
-          </a:prstGeom>
-          <a:noFill/>
-          <a:ln/>
-        </p:spPr>
-        <p:txBody>
-          <a:bodyPr wrap="square" lIns="0" tIns="0" rIns="0" bIns="0" rtlCol="0" anchor="t"/>
-          <a:lstStyle/>
-          <a:p>
-            <a:pPr indent="0" marL="0">
-              <a:buNone/>
-            </a:pPr>
-            <a:r>
-              <a:rPr lang="en-US" sz="950" b="1" dirty="0">
+              <a:t>Stated by Automatum — Partner Central evidence to attach</a:t>
+            </a:r>
+            <a:endParaRPr lang="en-US" sz="900" dirty="0"/>
+          </a:p>
+        </p:txBody>
+      </p:sp>
+      <p:sp>
+        <p:nvSpPr>
+          <p:cNvPr id="21" name="Text 17"/>
+          <p:cNvSpPr txBox="1"/>
+          <p:nvPr/>
+        </p:nvSpPr>
+        <p:spPr>
+          <a:xfrm>
+            <a:off x="749300" y="2819400"/>
+            <a:ext cx="4191000" cy="266700"/>
+          </a:xfrm>
+          <a:prstGeom prst="rect">
+            <a:avLst/>
+          </a:prstGeom>
+          <a:noFill/>
+          <a:ln/>
+        </p:spPr>
+        <p:txBody>
+          <a:bodyPr wrap="square" lIns="0" tIns="0" rIns="0" bIns="0" rtlCol="0" anchor="t"/>
+          <a:lstStyle/>
+          <a:p>
+            <a:pPr indent="0" marL="0">
+              <a:buNone/>
+            </a:pPr>
+            <a:r>
+              <a:rPr lang="en-US" sz="900" b="1" dirty="0">
                 <a:solidFill>
                   <a:srgbClr val="15224B"/>
                 </a:solidFill>
@@ -19111,36 +19131,36 @@
               </a:rPr>
               <a:t>Automatum is lead partner of record on all four Solution IDs</a:t>
             </a:r>
-            <a:endParaRPr lang="en-US" sz="950" dirty="0"/>
-          </a:p>
-        </p:txBody>
-      </p:sp>
-      <p:sp>
-        <p:nvSpPr>
-          <p:cNvPr id="21" name="Text 17"/>
-          <p:cNvSpPr txBox="1"/>
-          <p:nvPr/>
-        </p:nvSpPr>
-        <p:spPr>
-          <a:xfrm>
-            <a:off x="5143500" y="2921000"/>
-            <a:ext cx="1905000" cy="292100"/>
-          </a:xfrm>
-          <a:prstGeom prst="rect">
-            <a:avLst/>
-          </a:prstGeom>
-          <a:noFill/>
-          <a:ln/>
-        </p:spPr>
-        <p:txBody>
-          <a:bodyPr wrap="square" lIns="0" tIns="0" rIns="0" bIns="0" rtlCol="0" anchor="t"/>
-          <a:lstStyle/>
-          <a:p>
-            <a:pPr indent="0" marL="0">
-              <a:buNone/>
-            </a:pPr>
-            <a:r>
-              <a:rPr lang="en-US" sz="950" dirty="0">
+            <a:endParaRPr lang="en-US" sz="900" dirty="0"/>
+          </a:p>
+        </p:txBody>
+      </p:sp>
+      <p:sp>
+        <p:nvSpPr>
+          <p:cNvPr id="22" name="Text 18"/>
+          <p:cNvSpPr txBox="1"/>
+          <p:nvPr/>
+        </p:nvSpPr>
+        <p:spPr>
+          <a:xfrm>
+            <a:off x="5143500" y="2819400"/>
+            <a:ext cx="1905000" cy="266700"/>
+          </a:xfrm>
+          <a:prstGeom prst="rect">
+            <a:avLst/>
+          </a:prstGeom>
+          <a:noFill/>
+          <a:ln/>
+        </p:spPr>
+        <p:txBody>
+          <a:bodyPr wrap="square" lIns="0" tIns="0" rIns="0" bIns="0" rtlCol="0" anchor="t"/>
+          <a:lstStyle/>
+          <a:p>
+            <a:pPr indent="0" marL="0">
+              <a:buNone/>
+            </a:pPr>
+            <a:r>
+              <a:rPr lang="en-US" sz="900" dirty="0">
                 <a:solidFill>
                   <a:srgbClr val="5B6378"/>
                 </a:solidFill>
@@ -19150,36 +19170,36 @@
               </a:rPr>
               <a:t>Automatum</a:t>
             </a:r>
-            <a:endParaRPr lang="en-US" sz="950" dirty="0"/>
-          </a:p>
-        </p:txBody>
-      </p:sp>
-      <p:sp>
-        <p:nvSpPr>
-          <p:cNvPr id="22" name="Text 18"/>
-          <p:cNvSpPr txBox="1"/>
-          <p:nvPr/>
-        </p:nvSpPr>
-        <p:spPr>
-          <a:xfrm>
-            <a:off x="7366000" y="2921000"/>
-            <a:ext cx="2895600" cy="292100"/>
-          </a:xfrm>
-          <a:prstGeom prst="rect">
-            <a:avLst/>
-          </a:prstGeom>
-          <a:noFill/>
-          <a:ln/>
-        </p:spPr>
-        <p:txBody>
-          <a:bodyPr wrap="square" lIns="0" tIns="0" rIns="0" bIns="0" rtlCol="0" anchor="t"/>
-          <a:lstStyle/>
-          <a:p>
-            <a:pPr indent="0" marL="0">
-              <a:buNone/>
-            </a:pPr>
-            <a:r>
-              <a:rPr lang="en-US" sz="950" dirty="0">
+            <a:endParaRPr lang="en-US" sz="900" dirty="0"/>
+          </a:p>
+        </p:txBody>
+      </p:sp>
+      <p:sp>
+        <p:nvSpPr>
+          <p:cNvPr id="23" name="Text 19"/>
+          <p:cNvSpPr txBox="1"/>
+          <p:nvPr/>
+        </p:nvSpPr>
+        <p:spPr>
+          <a:xfrm>
+            <a:off x="7366000" y="2819400"/>
+            <a:ext cx="2895600" cy="266700"/>
+          </a:xfrm>
+          <a:prstGeom prst="rect">
+            <a:avLst/>
+          </a:prstGeom>
+          <a:noFill/>
+          <a:ln/>
+        </p:spPr>
+        <p:txBody>
+          <a:bodyPr wrap="square" lIns="0" tIns="0" rIns="0" bIns="0" rtlCol="0" anchor="t"/>
+          <a:lstStyle/>
+          <a:p>
+            <a:pPr indent="0" marL="0">
+              <a:buNone/>
+            </a:pPr>
+            <a:r>
+              <a:rPr lang="en-US" sz="900" dirty="0">
                 <a:solidFill>
                   <a:srgbClr val="5B6378"/>
                 </a:solidFill>
@@ -19189,36 +19209,36 @@
               </a:rPr>
               <a:t>To confirm</a:t>
             </a:r>
-            <a:endParaRPr lang="en-US" sz="950" dirty="0"/>
-          </a:p>
-        </p:txBody>
-      </p:sp>
-      <p:sp>
-        <p:nvSpPr>
-          <p:cNvPr id="23" name="Text 19"/>
-          <p:cNvSpPr txBox="1"/>
-          <p:nvPr/>
-        </p:nvSpPr>
-        <p:spPr>
-          <a:xfrm>
-            <a:off x="749300" y="3213100"/>
-            <a:ext cx="4191000" cy="292100"/>
-          </a:xfrm>
-          <a:prstGeom prst="rect">
-            <a:avLst/>
-          </a:prstGeom>
-          <a:noFill/>
-          <a:ln/>
-        </p:spPr>
-        <p:txBody>
-          <a:bodyPr wrap="square" lIns="0" tIns="0" rIns="0" bIns="0" rtlCol="0" anchor="t"/>
-          <a:lstStyle/>
-          <a:p>
-            <a:pPr indent="0" marL="0">
-              <a:buNone/>
-            </a:pPr>
-            <a:r>
-              <a:rPr lang="en-US" sz="950" b="1" dirty="0">
+            <a:endParaRPr lang="en-US" sz="900" dirty="0"/>
+          </a:p>
+        </p:txBody>
+      </p:sp>
+      <p:sp>
+        <p:nvSpPr>
+          <p:cNvPr id="24" name="Text 20"/>
+          <p:cNvSpPr txBox="1"/>
+          <p:nvPr/>
+        </p:nvSpPr>
+        <p:spPr>
+          <a:xfrm>
+            <a:off x="749300" y="3086100"/>
+            <a:ext cx="4191000" cy="266700"/>
+          </a:xfrm>
+          <a:prstGeom prst="rect">
+            <a:avLst/>
+          </a:prstGeom>
+          <a:noFill/>
+          <a:ln/>
+        </p:spPr>
+        <p:txBody>
+          <a:bodyPr wrap="square" lIns="0" tIns="0" rIns="0" bIns="0" rtlCol="0" anchor="t"/>
+          <a:lstStyle/>
+          <a:p>
+            <a:pPr indent="0" marL="0">
+              <a:buNone/>
+            </a:pPr>
+            <a:r>
+              <a:rPr lang="en-US" sz="900" b="1" dirty="0">
                 <a:solidFill>
                   <a:srgbClr val="15224B"/>
                 </a:solidFill>
@@ -19228,36 +19248,36 @@
               </a:rPr>
               <a:t>Solution listed within 12 months</a:t>
             </a:r>
-            <a:endParaRPr lang="en-US" sz="950" dirty="0"/>
-          </a:p>
-        </p:txBody>
-      </p:sp>
-      <p:sp>
-        <p:nvSpPr>
-          <p:cNvPr id="24" name="Text 20"/>
-          <p:cNvSpPr txBox="1"/>
-          <p:nvPr/>
-        </p:nvSpPr>
-        <p:spPr>
-          <a:xfrm>
-            <a:off x="5143500" y="3213100"/>
-            <a:ext cx="1905000" cy="292100"/>
-          </a:xfrm>
-          <a:prstGeom prst="rect">
-            <a:avLst/>
-          </a:prstGeom>
-          <a:noFill/>
-          <a:ln/>
-        </p:spPr>
-        <p:txBody>
-          <a:bodyPr wrap="square" lIns="0" tIns="0" rIns="0" bIns="0" rtlCol="0" anchor="t"/>
-          <a:lstStyle/>
-          <a:p>
-            <a:pPr indent="0" marL="0">
-              <a:buNone/>
-            </a:pPr>
-            <a:r>
-              <a:rPr lang="en-US" sz="950" dirty="0">
+            <a:endParaRPr lang="en-US" sz="900" dirty="0"/>
+          </a:p>
+        </p:txBody>
+      </p:sp>
+      <p:sp>
+        <p:nvSpPr>
+          <p:cNvPr id="25" name="Text 21"/>
+          <p:cNvSpPr txBox="1"/>
+          <p:nvPr/>
+        </p:nvSpPr>
+        <p:spPr>
+          <a:xfrm>
+            <a:off x="5143500" y="3086100"/>
+            <a:ext cx="1905000" cy="266700"/>
+          </a:xfrm>
+          <a:prstGeom prst="rect">
+            <a:avLst/>
+          </a:prstGeom>
+          <a:noFill/>
+          <a:ln/>
+        </p:spPr>
+        <p:txBody>
+          <a:bodyPr wrap="square" lIns="0" tIns="0" rIns="0" bIns="0" rtlCol="0" anchor="t"/>
+          <a:lstStyle/>
+          <a:p>
+            <a:pPr indent="0" marL="0">
+              <a:buNone/>
+            </a:pPr>
+            <a:r>
+              <a:rPr lang="en-US" sz="900" dirty="0">
                 <a:solidFill>
                   <a:srgbClr val="5B6378"/>
                 </a:solidFill>
@@ -19267,36 +19287,36 @@
               </a:rPr>
               <a:t>Automatum + OBP</a:t>
             </a:r>
-            <a:endParaRPr lang="en-US" sz="950" dirty="0"/>
-          </a:p>
-        </p:txBody>
-      </p:sp>
-      <p:sp>
-        <p:nvSpPr>
-          <p:cNvPr id="25" name="Text 21"/>
-          <p:cNvSpPr txBox="1"/>
-          <p:nvPr/>
-        </p:nvSpPr>
-        <p:spPr>
-          <a:xfrm>
-            <a:off x="7366000" y="3213100"/>
-            <a:ext cx="2895600" cy="292100"/>
-          </a:xfrm>
-          <a:prstGeom prst="rect">
-            <a:avLst/>
-          </a:prstGeom>
-          <a:noFill/>
-          <a:ln/>
-        </p:spPr>
-        <p:txBody>
-          <a:bodyPr wrap="square" lIns="0" tIns="0" rIns="0" bIns="0" rtlCol="0" anchor="t"/>
-          <a:lstStyle/>
-          <a:p>
-            <a:pPr indent="0" marL="0">
-              <a:buNone/>
-            </a:pPr>
-            <a:r>
-              <a:rPr lang="en-US" sz="950" dirty="0">
+            <a:endParaRPr lang="en-US" sz="900" dirty="0"/>
+          </a:p>
+        </p:txBody>
+      </p:sp>
+      <p:sp>
+        <p:nvSpPr>
+          <p:cNvPr id="26" name="Text 22"/>
+          <p:cNvSpPr txBox="1"/>
+          <p:nvPr/>
+        </p:nvSpPr>
+        <p:spPr>
+          <a:xfrm>
+            <a:off x="7366000" y="3086100"/>
+            <a:ext cx="2895600" cy="266700"/>
+          </a:xfrm>
+          <a:prstGeom prst="rect">
+            <a:avLst/>
+          </a:prstGeom>
+          <a:noFill/>
+          <a:ln/>
+        </p:spPr>
+        <p:txBody>
+          <a:bodyPr wrap="square" lIns="0" tIns="0" rIns="0" bIns="0" rtlCol="0" anchor="t"/>
+          <a:lstStyle/>
+          <a:p>
+            <a:pPr indent="0" marL="0">
+              <a:buNone/>
+            </a:pPr>
+            <a:r>
+              <a:rPr lang="en-US" sz="900" dirty="0">
                 <a:solidFill>
                   <a:srgbClr val="5B6378"/>
                 </a:solidFill>
@@ -19306,36 +19326,36 @@
               </a:rPr>
               <a:t>[Per-wave deadlines once the clock basis is confirmed]</a:t>
             </a:r>
-            <a:endParaRPr lang="en-US" sz="950" dirty="0"/>
-          </a:p>
-        </p:txBody>
-      </p:sp>
-      <p:sp>
-        <p:nvSpPr>
-          <p:cNvPr id="26" name="Text 22"/>
-          <p:cNvSpPr txBox="1"/>
-          <p:nvPr/>
-        </p:nvSpPr>
-        <p:spPr>
-          <a:xfrm>
-            <a:off x="749300" y="3505200"/>
-            <a:ext cx="4191000" cy="292100"/>
-          </a:xfrm>
-          <a:prstGeom prst="rect">
-            <a:avLst/>
-          </a:prstGeom>
-          <a:noFill/>
-          <a:ln/>
-        </p:spPr>
-        <p:txBody>
-          <a:bodyPr wrap="square" lIns="0" tIns="0" rIns="0" bIns="0" rtlCol="0" anchor="t"/>
-          <a:lstStyle/>
-          <a:p>
-            <a:pPr indent="0" marL="0">
-              <a:buNone/>
-            </a:pPr>
-            <a:r>
-              <a:rPr lang="en-US" sz="950" b="1" dirty="0">
+            <a:endParaRPr lang="en-US" sz="900" dirty="0"/>
+          </a:p>
+        </p:txBody>
+      </p:sp>
+      <p:sp>
+        <p:nvSpPr>
+          <p:cNvPr id="27" name="Text 23"/>
+          <p:cNvSpPr txBox="1"/>
+          <p:nvPr/>
+        </p:nvSpPr>
+        <p:spPr>
+          <a:xfrm>
+            <a:off x="749300" y="3352800"/>
+            <a:ext cx="4191000" cy="266700"/>
+          </a:xfrm>
+          <a:prstGeom prst="rect">
+            <a:avLst/>
+          </a:prstGeom>
+          <a:noFill/>
+          <a:ln/>
+        </p:spPr>
+        <p:txBody>
+          <a:bodyPr wrap="square" lIns="0" tIns="0" rIns="0" bIns="0" rtlCol="0" anchor="t"/>
+          <a:lstStyle/>
+          <a:p>
+            <a:pPr indent="0" marL="0">
+              <a:buNone/>
+            </a:pPr>
+            <a:r>
+              <a:rPr lang="en-US" sz="900" b="1" dirty="0">
                 <a:solidFill>
                   <a:srgbClr val="15224B"/>
                 </a:solidFill>
@@ -19345,36 +19365,36 @@
               </a:rPr>
               <a:t>Five ACE opportunity submissions per solution</a:t>
             </a:r>
-            <a:endParaRPr lang="en-US" sz="950" dirty="0"/>
-          </a:p>
-        </p:txBody>
-      </p:sp>
-      <p:sp>
-        <p:nvSpPr>
-          <p:cNvPr id="27" name="Text 23"/>
-          <p:cNvSpPr txBox="1"/>
-          <p:nvPr/>
-        </p:nvSpPr>
-        <p:spPr>
-          <a:xfrm>
-            <a:off x="5143500" y="3505200"/>
-            <a:ext cx="1905000" cy="292100"/>
-          </a:xfrm>
-          <a:prstGeom prst="rect">
-            <a:avLst/>
-          </a:prstGeom>
-          <a:noFill/>
-          <a:ln/>
-        </p:spPr>
-        <p:txBody>
-          <a:bodyPr wrap="square" lIns="0" tIns="0" rIns="0" bIns="0" rtlCol="0" anchor="t"/>
-          <a:lstStyle/>
-          <a:p>
-            <a:pPr indent="0" marL="0">
-              <a:buNone/>
-            </a:pPr>
-            <a:r>
-              <a:rPr lang="en-US" sz="950" dirty="0">
+            <a:endParaRPr lang="en-US" sz="900" dirty="0"/>
+          </a:p>
+        </p:txBody>
+      </p:sp>
+      <p:sp>
+        <p:nvSpPr>
+          <p:cNvPr id="28" name="Text 24"/>
+          <p:cNvSpPr txBox="1"/>
+          <p:nvPr/>
+        </p:nvSpPr>
+        <p:spPr>
+          <a:xfrm>
+            <a:off x="5143500" y="3352800"/>
+            <a:ext cx="1905000" cy="266700"/>
+          </a:xfrm>
+          <a:prstGeom prst="rect">
+            <a:avLst/>
+          </a:prstGeom>
+          <a:noFill/>
+          <a:ln/>
+        </p:spPr>
+        <p:txBody>
+          <a:bodyPr wrap="square" lIns="0" tIns="0" rIns="0" bIns="0" rtlCol="0" anchor="t"/>
+          <a:lstStyle/>
+          <a:p>
+            <a:pPr indent="0" marL="0">
+              <a:buNone/>
+            </a:pPr>
+            <a:r>
+              <a:rPr lang="en-US" sz="900" dirty="0">
                 <a:solidFill>
                   <a:srgbClr val="5B6378"/>
                 </a:solidFill>
@@ -19384,36 +19404,36 @@
               </a:rPr>
               <a:t>OBP</a:t>
             </a:r>
-            <a:endParaRPr lang="en-US" sz="950" dirty="0"/>
-          </a:p>
-        </p:txBody>
-      </p:sp>
-      <p:sp>
-        <p:nvSpPr>
-          <p:cNvPr id="28" name="Text 24"/>
-          <p:cNvSpPr txBox="1"/>
-          <p:nvPr/>
-        </p:nvSpPr>
-        <p:spPr>
-          <a:xfrm>
-            <a:off x="7366000" y="3505200"/>
-            <a:ext cx="2895600" cy="292100"/>
-          </a:xfrm>
-          <a:prstGeom prst="rect">
-            <a:avLst/>
-          </a:prstGeom>
-          <a:noFill/>
-          <a:ln/>
-        </p:spPr>
-        <p:txBody>
-          <a:bodyPr wrap="square" lIns="0" tIns="0" rIns="0" bIns="0" rtlCol="0" anchor="t"/>
-          <a:lstStyle/>
-          <a:p>
-            <a:pPr indent="0" marL="0">
-              <a:buNone/>
-            </a:pPr>
-            <a:r>
-              <a:rPr lang="en-US" sz="950" dirty="0">
+            <a:endParaRPr lang="en-US" sz="900" dirty="0"/>
+          </a:p>
+        </p:txBody>
+      </p:sp>
+      <p:sp>
+        <p:nvSpPr>
+          <p:cNvPr id="29" name="Text 25"/>
+          <p:cNvSpPr txBox="1"/>
+          <p:nvPr/>
+        </p:nvSpPr>
+        <p:spPr>
+          <a:xfrm>
+            <a:off x="7366000" y="3352800"/>
+            <a:ext cx="2895600" cy="266700"/>
+          </a:xfrm>
+          <a:prstGeom prst="rect">
+            <a:avLst/>
+          </a:prstGeom>
+          <a:noFill/>
+          <a:ln/>
+        </p:spPr>
+        <p:txBody>
+          <a:bodyPr wrap="square" lIns="0" tIns="0" rIns="0" bIns="0" rtlCol="0" anchor="t"/>
+          <a:lstStyle/>
+          <a:p>
+            <a:pPr indent="0" marL="0">
+              <a:buNone/>
+            </a:pPr>
+            <a:r>
+              <a:rPr lang="en-US" sz="900" dirty="0">
                 <a:solidFill>
                   <a:srgbClr val="5B6378"/>
                 </a:solidFill>
@@ -19423,36 +19443,36 @@
               </a:rPr>
               <a:t>Built into each solution’s plan</a:t>
             </a:r>
-            <a:endParaRPr lang="en-US" sz="950" dirty="0"/>
-          </a:p>
-        </p:txBody>
-      </p:sp>
-      <p:sp>
-        <p:nvSpPr>
-          <p:cNvPr id="29" name="Text 25"/>
-          <p:cNvSpPr txBox="1"/>
-          <p:nvPr/>
-        </p:nvSpPr>
-        <p:spPr>
-          <a:xfrm>
-            <a:off x="749300" y="3797300"/>
-            <a:ext cx="4191000" cy="292100"/>
-          </a:xfrm>
-          <a:prstGeom prst="rect">
-            <a:avLst/>
-          </a:prstGeom>
-          <a:noFill/>
-          <a:ln/>
-        </p:spPr>
-        <p:txBody>
-          <a:bodyPr wrap="square" lIns="0" tIns="0" rIns="0" bIns="0" rtlCol="0" anchor="t"/>
-          <a:lstStyle/>
-          <a:p>
-            <a:pPr indent="0" marL="0">
-              <a:buNone/>
-            </a:pPr>
-            <a:r>
-              <a:rPr lang="en-US" sz="950" b="1" dirty="0">
+            <a:endParaRPr lang="en-US" sz="900" dirty="0"/>
+          </a:p>
+        </p:txBody>
+      </p:sp>
+      <p:sp>
+        <p:nvSpPr>
+          <p:cNvPr id="30" name="Text 26"/>
+          <p:cNvSpPr txBox="1"/>
+          <p:nvPr/>
+        </p:nvSpPr>
+        <p:spPr>
+          <a:xfrm>
+            <a:off x="749300" y="3619500"/>
+            <a:ext cx="4191000" cy="266700"/>
+          </a:xfrm>
+          <a:prstGeom prst="rect">
+            <a:avLst/>
+          </a:prstGeom>
+          <a:noFill/>
+          <a:ln/>
+        </p:spPr>
+        <p:txBody>
+          <a:bodyPr wrap="square" lIns="0" tIns="0" rIns="0" bIns="0" rtlCol="0" anchor="t"/>
+          <a:lstStyle/>
+          <a:p>
+            <a:pPr indent="0" marL="0">
+              <a:buNone/>
+            </a:pPr>
+            <a:r>
+              <a:rPr lang="en-US" sz="900" b="1" dirty="0">
                 <a:solidFill>
                   <a:srgbClr val="15224B"/>
                 </a:solidFill>
@@ -19462,36 +19482,36 @@
               </a:rPr>
               <a:t>Milestone 1 Feasibility Study per solution</a:t>
             </a:r>
-            <a:endParaRPr lang="en-US" sz="950" dirty="0"/>
-          </a:p>
-        </p:txBody>
-      </p:sp>
-      <p:sp>
-        <p:nvSpPr>
-          <p:cNvPr id="30" name="Text 26"/>
-          <p:cNvSpPr txBox="1"/>
-          <p:nvPr/>
-        </p:nvSpPr>
-        <p:spPr>
-          <a:xfrm>
-            <a:off x="5143500" y="3797300"/>
-            <a:ext cx="1905000" cy="292100"/>
-          </a:xfrm>
-          <a:prstGeom prst="rect">
-            <a:avLst/>
-          </a:prstGeom>
-          <a:noFill/>
-          <a:ln/>
-        </p:spPr>
-        <p:txBody>
-          <a:bodyPr wrap="square" lIns="0" tIns="0" rIns="0" bIns="0" rtlCol="0" anchor="t"/>
-          <a:lstStyle/>
-          <a:p>
-            <a:pPr indent="0" marL="0">
-              <a:buNone/>
-            </a:pPr>
-            <a:r>
-              <a:rPr lang="en-US" sz="950" dirty="0">
+            <a:endParaRPr lang="en-US" sz="900" dirty="0"/>
+          </a:p>
+        </p:txBody>
+      </p:sp>
+      <p:sp>
+        <p:nvSpPr>
+          <p:cNvPr id="31" name="Text 27"/>
+          <p:cNvSpPr txBox="1"/>
+          <p:nvPr/>
+        </p:nvSpPr>
+        <p:spPr>
+          <a:xfrm>
+            <a:off x="5143500" y="3619500"/>
+            <a:ext cx="1905000" cy="266700"/>
+          </a:xfrm>
+          <a:prstGeom prst="rect">
+            <a:avLst/>
+          </a:prstGeom>
+          <a:noFill/>
+          <a:ln/>
+        </p:spPr>
+        <p:txBody>
+          <a:bodyPr wrap="square" lIns="0" tIns="0" rIns="0" bIns="0" rtlCol="0" anchor="t"/>
+          <a:lstStyle/>
+          <a:p>
+            <a:pPr indent="0" marL="0">
+              <a:buNone/>
+            </a:pPr>
+            <a:r>
+              <a:rPr lang="en-US" sz="900" dirty="0">
                 <a:solidFill>
                   <a:srgbClr val="5B6378"/>
                 </a:solidFill>
@@ -19501,36 +19521,36 @@
               </a:rPr>
               <a:t>OBP</a:t>
             </a:r>
-            <a:endParaRPr lang="en-US" sz="950" dirty="0"/>
-          </a:p>
-        </p:txBody>
-      </p:sp>
-      <p:sp>
-        <p:nvSpPr>
-          <p:cNvPr id="31" name="Text 27"/>
-          <p:cNvSpPr txBox="1"/>
-          <p:nvPr/>
-        </p:nvSpPr>
-        <p:spPr>
-          <a:xfrm>
-            <a:off x="7366000" y="3797300"/>
-            <a:ext cx="2895600" cy="292100"/>
-          </a:xfrm>
-          <a:prstGeom prst="rect">
-            <a:avLst/>
-          </a:prstGeom>
-          <a:noFill/>
-          <a:ln/>
-        </p:spPr>
-        <p:txBody>
-          <a:bodyPr wrap="square" lIns="0" tIns="0" rIns="0" bIns="0" rtlCol="0" anchor="t"/>
-          <a:lstStyle/>
-          <a:p>
-            <a:pPr indent="0" marL="0">
-              <a:buNone/>
-            </a:pPr>
-            <a:r>
-              <a:rPr lang="en-US" sz="950" dirty="0">
+            <a:endParaRPr lang="en-US" sz="900" dirty="0"/>
+          </a:p>
+        </p:txBody>
+      </p:sp>
+      <p:sp>
+        <p:nvSpPr>
+          <p:cNvPr id="32" name="Text 28"/>
+          <p:cNvSpPr txBox="1"/>
+          <p:nvPr/>
+        </p:nvSpPr>
+        <p:spPr>
+          <a:xfrm>
+            <a:off x="7366000" y="3619500"/>
+            <a:ext cx="2895600" cy="266700"/>
+          </a:xfrm>
+          <a:prstGeom prst="rect">
+            <a:avLst/>
+          </a:prstGeom>
+          <a:noFill/>
+          <a:ln/>
+        </p:spPr>
+        <p:txBody>
+          <a:bodyPr wrap="square" lIns="0" tIns="0" rIns="0" bIns="0" rtlCol="0" anchor="t"/>
+          <a:lstStyle/>
+          <a:p>
+            <a:pPr indent="0" marL="0">
+              <a:buNone/>
+            </a:pPr>
+            <a:r>
+              <a:rPr lang="en-US" sz="900" dirty="0">
                 <a:solidFill>
                   <a:srgbClr val="5B6378"/>
                 </a:solidFill>
@@ -19540,36 +19560,36 @@
               </a:rPr>
               <a:t>Drafted from the overviews</a:t>
             </a:r>
-            <a:endParaRPr lang="en-US" sz="950" dirty="0"/>
-          </a:p>
-        </p:txBody>
-      </p:sp>
-      <p:sp>
-        <p:nvSpPr>
-          <p:cNvPr id="32" name="Text 28"/>
-          <p:cNvSpPr txBox="1"/>
-          <p:nvPr/>
-        </p:nvSpPr>
-        <p:spPr>
-          <a:xfrm>
-            <a:off x="749300" y="4089400"/>
-            <a:ext cx="4191000" cy="292100"/>
-          </a:xfrm>
-          <a:prstGeom prst="rect">
-            <a:avLst/>
-          </a:prstGeom>
-          <a:noFill/>
-          <a:ln/>
-        </p:spPr>
-        <p:txBody>
-          <a:bodyPr wrap="square" lIns="0" tIns="0" rIns="0" bIns="0" rtlCol="0" anchor="t"/>
-          <a:lstStyle/>
-          <a:p>
-            <a:pPr indent="0" marL="0">
-              <a:buNone/>
-            </a:pPr>
-            <a:r>
-              <a:rPr lang="en-US" sz="950" b="1" dirty="0">
+            <a:endParaRPr lang="en-US" sz="900" dirty="0"/>
+          </a:p>
+        </p:txBody>
+      </p:sp>
+      <p:sp>
+        <p:nvSpPr>
+          <p:cNvPr id="33" name="Text 29"/>
+          <p:cNvSpPr txBox="1"/>
+          <p:nvPr/>
+        </p:nvSpPr>
+        <p:spPr>
+          <a:xfrm>
+            <a:off x="749300" y="3886200"/>
+            <a:ext cx="4191000" cy="266700"/>
+          </a:xfrm>
+          <a:prstGeom prst="rect">
+            <a:avLst/>
+          </a:prstGeom>
+          <a:noFill/>
+          <a:ln/>
+        </p:spPr>
+        <p:txBody>
+          <a:bodyPr wrap="square" lIns="0" tIns="0" rIns="0" bIns="0" rtlCol="0" anchor="t"/>
+          <a:lstStyle/>
+          <a:p>
+            <a:pPr indent="0" marL="0">
+              <a:buNone/>
+            </a:pPr>
+            <a:r>
+              <a:rPr lang="en-US" sz="900" b="1" dirty="0">
                 <a:solidFill>
                   <a:srgbClr val="15224B"/>
                 </a:solidFill>
@@ -19577,38 +19597,38 @@
                 <a:ea typeface="Segoe UI" pitchFamily="34" charset="-122"/>
                 <a:cs typeface="Segoe UI" pitchFamily="34" charset="-120"/>
               </a:rPr>
-              <a:t>Commit / target set per retainer rung</a:t>
-            </a:r>
-            <a:endParaRPr lang="en-US" sz="950" dirty="0"/>
-          </a:p>
-        </p:txBody>
-      </p:sp>
-      <p:sp>
-        <p:nvSpPr>
-          <p:cNvPr id="33" name="Text 29"/>
-          <p:cNvSpPr txBox="1"/>
-          <p:nvPr/>
-        </p:nvSpPr>
-        <p:spPr>
-          <a:xfrm>
-            <a:off x="5143500" y="4089400"/>
-            <a:ext cx="1905000" cy="292100"/>
-          </a:xfrm>
-          <a:prstGeom prst="rect">
-            <a:avLst/>
-          </a:prstGeom>
-          <a:noFill/>
-          <a:ln/>
-        </p:spPr>
-        <p:txBody>
-          <a:bodyPr wrap="square" lIns="0" tIns="0" rIns="0" bIns="0" rtlCol="0" anchor="t"/>
-          <a:lstStyle/>
-          <a:p>
-            <a:pPr indent="0" marL="0">
-              <a:buNone/>
-            </a:pPr>
-            <a:r>
-              <a:rPr lang="en-US" sz="950" dirty="0">
+              <a:t>Retainer outcomes per rung</a:t>
+            </a:r>
+            <a:endParaRPr lang="en-US" sz="900" dirty="0"/>
+          </a:p>
+        </p:txBody>
+      </p:sp>
+      <p:sp>
+        <p:nvSpPr>
+          <p:cNvPr id="34" name="Text 30"/>
+          <p:cNvSpPr txBox="1"/>
+          <p:nvPr/>
+        </p:nvSpPr>
+        <p:spPr>
+          <a:xfrm>
+            <a:off x="5143500" y="3886200"/>
+            <a:ext cx="1905000" cy="266700"/>
+          </a:xfrm>
+          <a:prstGeom prst="rect">
+            <a:avLst/>
+          </a:prstGeom>
+          <a:noFill/>
+          <a:ln/>
+        </p:spPr>
+        <p:txBody>
+          <a:bodyPr wrap="square" lIns="0" tIns="0" rIns="0" bIns="0" rtlCol="0" anchor="t"/>
+          <a:lstStyle/>
+          <a:p>
+            <a:pPr indent="0" marL="0">
+              <a:buNone/>
+            </a:pPr>
+            <a:r>
+              <a:rPr lang="en-US" sz="900" dirty="0">
                 <a:solidFill>
                   <a:srgbClr val="5B6378"/>
                 </a:solidFill>
@@ -19618,36 +19638,36 @@
               </a:rPr>
               <a:t>OBP</a:t>
             </a:r>
-            <a:endParaRPr lang="en-US" sz="950" dirty="0"/>
-          </a:p>
-        </p:txBody>
-      </p:sp>
-      <p:sp>
-        <p:nvSpPr>
-          <p:cNvPr id="34" name="Text 30"/>
-          <p:cNvSpPr txBox="1"/>
-          <p:nvPr/>
-        </p:nvSpPr>
-        <p:spPr>
-          <a:xfrm>
-            <a:off x="7366000" y="4089400"/>
-            <a:ext cx="2895600" cy="292100"/>
-          </a:xfrm>
-          <a:prstGeom prst="rect">
-            <a:avLst/>
-          </a:prstGeom>
-          <a:noFill/>
-          <a:ln/>
-        </p:spPr>
-        <p:txBody>
-          <a:bodyPr wrap="square" lIns="0" tIns="0" rIns="0" bIns="0" rtlCol="0" anchor="t"/>
-          <a:lstStyle/>
-          <a:p>
-            <a:pPr indent="0" marL="0">
-              <a:buNone/>
-            </a:pPr>
-            <a:r>
-              <a:rPr lang="en-US" sz="950" dirty="0">
+            <a:endParaRPr lang="en-US" sz="900" dirty="0"/>
+          </a:p>
+        </p:txBody>
+      </p:sp>
+      <p:sp>
+        <p:nvSpPr>
+          <p:cNvPr id="35" name="Text 31"/>
+          <p:cNvSpPr txBox="1"/>
+          <p:nvPr/>
+        </p:nvSpPr>
+        <p:spPr>
+          <a:xfrm>
+            <a:off x="7366000" y="3886200"/>
+            <a:ext cx="2895600" cy="266700"/>
+          </a:xfrm>
+          <a:prstGeom prst="rect">
+            <a:avLst/>
+          </a:prstGeom>
+          <a:noFill/>
+          <a:ln/>
+        </p:spPr>
+        <p:txBody>
+          <a:bodyPr wrap="square" lIns="0" tIns="0" rIns="0" bIns="0" rtlCol="0" anchor="t"/>
+          <a:lstStyle/>
+          <a:p>
+            <a:pPr indent="0" marL="0">
+              <a:buNone/>
+            </a:pPr>
+            <a:r>
+              <a:rPr lang="en-US" sz="900" dirty="0">
                 <a:solidFill>
                   <a:srgbClr val="5B6378"/>
                 </a:solidFill>
@@ -19655,38 +19675,38 @@
                 <a:ea typeface="Segoe UI Semilight" pitchFamily="34" charset="-122"/>
                 <a:cs typeface="Segoe UI Semilight" pitchFamily="34" charset="-120"/>
               </a:rPr>
-              <a:t>In draft — placeholders to close by [date]</a:t>
-            </a:r>
-            <a:endParaRPr lang="en-US" sz="950" dirty="0"/>
-          </a:p>
-        </p:txBody>
-      </p:sp>
-      <p:sp>
-        <p:nvSpPr>
-          <p:cNvPr id="35" name="Text 31"/>
-          <p:cNvSpPr txBox="1"/>
-          <p:nvPr/>
-        </p:nvSpPr>
-        <p:spPr>
-          <a:xfrm>
-            <a:off x="749300" y="4381500"/>
-            <a:ext cx="4191000" cy="292100"/>
-          </a:xfrm>
-          <a:prstGeom prst="rect">
-            <a:avLst/>
-          </a:prstGeom>
-          <a:noFill/>
-          <a:ln/>
-        </p:spPr>
-        <p:txBody>
-          <a:bodyPr wrap="square" lIns="0" tIns="0" rIns="0" bIns="0" rtlCol="0" anchor="t"/>
-          <a:lstStyle/>
-          <a:p>
-            <a:pPr indent="0" marL="0">
-              <a:buNone/>
-            </a:pPr>
-            <a:r>
-              <a:rPr lang="en-US" sz="950" b="1" dirty="0">
+              <a:t>Set — all three retainers</a:t>
+            </a:r>
+            <a:endParaRPr lang="en-US" sz="900" dirty="0"/>
+          </a:p>
+        </p:txBody>
+      </p:sp>
+      <p:sp>
+        <p:nvSpPr>
+          <p:cNvPr id="36" name="Text 32"/>
+          <p:cNvSpPr txBox="1"/>
+          <p:nvPr/>
+        </p:nvSpPr>
+        <p:spPr>
+          <a:xfrm>
+            <a:off x="749300" y="4152900"/>
+            <a:ext cx="4191000" cy="266700"/>
+          </a:xfrm>
+          <a:prstGeom prst="rect">
+            <a:avLst/>
+          </a:prstGeom>
+          <a:noFill/>
+          <a:ln/>
+        </p:spPr>
+        <p:txBody>
+          <a:bodyPr wrap="square" lIns="0" tIns="0" rIns="0" bIns="0" rtlCol="0" anchor="t"/>
+          <a:lstStyle/>
+          <a:p>
+            <a:pPr indent="0" marL="0">
+              <a:buNone/>
+            </a:pPr>
+            <a:r>
+              <a:rPr lang="en-US" sz="900" b="1" dirty="0">
                 <a:solidFill>
                   <a:srgbClr val="15224B"/>
                 </a:solidFill>
@@ -19694,38 +19714,38 @@
                 <a:ea typeface="Segoe UI" pitchFamily="34" charset="-122"/>
                 <a:cs typeface="Segoe UI" pitchFamily="34" charset="-120"/>
               </a:rPr>
-              <a:t>Included band and overflow rate per rung</a:t>
-            </a:r>
-            <a:endParaRPr lang="en-US" sz="950" dirty="0"/>
-          </a:p>
-        </p:txBody>
-      </p:sp>
-      <p:sp>
-        <p:nvSpPr>
-          <p:cNvPr id="36" name="Text 32"/>
-          <p:cNvSpPr txBox="1"/>
-          <p:nvPr/>
-        </p:nvSpPr>
-        <p:spPr>
-          <a:xfrm>
-            <a:off x="5143500" y="4381500"/>
-            <a:ext cx="1905000" cy="292100"/>
-          </a:xfrm>
-          <a:prstGeom prst="rect">
-            <a:avLst/>
-          </a:prstGeom>
-          <a:noFill/>
-          <a:ln/>
-        </p:spPr>
-        <p:txBody>
-          <a:bodyPr wrap="square" lIns="0" tIns="0" rIns="0" bIns="0" rtlCol="0" anchor="t"/>
-          <a:lstStyle/>
-          <a:p>
-            <a:pPr indent="0" marL="0">
-              <a:buNone/>
-            </a:pPr>
-            <a:r>
-              <a:rPr lang="en-US" sz="950" dirty="0">
+              <a:t>Staffing, bands and overflow rates behind every rung</a:t>
+            </a:r>
+            <a:endParaRPr lang="en-US" sz="900" dirty="0"/>
+          </a:p>
+        </p:txBody>
+      </p:sp>
+      <p:sp>
+        <p:nvSpPr>
+          <p:cNvPr id="37" name="Text 33"/>
+          <p:cNvSpPr txBox="1"/>
+          <p:nvPr/>
+        </p:nvSpPr>
+        <p:spPr>
+          <a:xfrm>
+            <a:off x="5143500" y="4152900"/>
+            <a:ext cx="1905000" cy="266700"/>
+          </a:xfrm>
+          <a:prstGeom prst="rect">
+            <a:avLst/>
+          </a:prstGeom>
+          <a:noFill/>
+          <a:ln/>
+        </p:spPr>
+        <p:txBody>
+          <a:bodyPr wrap="square" lIns="0" tIns="0" rIns="0" bIns="0" rtlCol="0" anchor="t"/>
+          <a:lstStyle/>
+          <a:p>
+            <a:pPr indent="0" marL="0">
+              <a:buNone/>
+            </a:pPr>
+            <a:r>
+              <a:rPr lang="en-US" sz="900" dirty="0">
                 <a:solidFill>
                   <a:srgbClr val="5B6378"/>
                 </a:solidFill>
@@ -19733,38 +19753,38 @@
                 <a:ea typeface="Segoe UI Semilight" pitchFamily="34" charset="-122"/>
                 <a:cs typeface="Segoe UI Semilight" pitchFamily="34" charset="-120"/>
               </a:rPr>
-              <a:t>OBP commercial</a:t>
-            </a:r>
-            <a:endParaRPr lang="en-US" sz="950" dirty="0"/>
-          </a:p>
-        </p:txBody>
-      </p:sp>
-      <p:sp>
-        <p:nvSpPr>
-          <p:cNvPr id="37" name="Text 33"/>
-          <p:cNvSpPr txBox="1"/>
-          <p:nvPr/>
-        </p:nvSpPr>
-        <p:spPr>
-          <a:xfrm>
-            <a:off x="7366000" y="4381500"/>
-            <a:ext cx="2895600" cy="292100"/>
-          </a:xfrm>
-          <a:prstGeom prst="rect">
-            <a:avLst/>
-          </a:prstGeom>
-          <a:noFill/>
-          <a:ln/>
-        </p:spPr>
-        <p:txBody>
-          <a:bodyPr wrap="square" lIns="0" tIns="0" rIns="0" bIns="0" rtlCol="0" anchor="t"/>
-          <a:lstStyle/>
-          <a:p>
-            <a:pPr indent="0" marL="0">
-              <a:buNone/>
-            </a:pPr>
-            <a:r>
-              <a:rPr lang="en-US" sz="950" dirty="0">
+              <a:t>OBP</a:t>
+            </a:r>
+            <a:endParaRPr lang="en-US" sz="900" dirty="0"/>
+          </a:p>
+        </p:txBody>
+      </p:sp>
+      <p:sp>
+        <p:nvSpPr>
+          <p:cNvPr id="38" name="Text 34"/>
+          <p:cNvSpPr txBox="1"/>
+          <p:nvPr/>
+        </p:nvSpPr>
+        <p:spPr>
+          <a:xfrm>
+            <a:off x="7366000" y="4152900"/>
+            <a:ext cx="2895600" cy="266700"/>
+          </a:xfrm>
+          <a:prstGeom prst="rect">
+            <a:avLst/>
+          </a:prstGeom>
+          <a:noFill/>
+          <a:ln/>
+        </p:spPr>
+        <p:txBody>
+          <a:bodyPr wrap="square" lIns="0" tIns="0" rIns="0" bIns="0" rtlCol="0" anchor="t"/>
+          <a:lstStyle/>
+          <a:p>
+            <a:pPr indent="0" marL="0">
+              <a:buNone/>
+            </a:pPr>
+            <a:r>
+              <a:rPr lang="en-US" sz="900" dirty="0">
                 <a:solidFill>
                   <a:srgbClr val="5B6378"/>
                 </a:solidFill>
@@ -19772,38 +19792,38 @@
                 <a:ea typeface="Segoe UI Semilight" pitchFamily="34" charset="-122"/>
                 <a:cs typeface="Segoe UI Semilight" pitchFamily="34" charset="-120"/>
               </a:rPr>
-              <a:t>To decide</a:t>
-            </a:r>
-            <a:endParaRPr lang="en-US" sz="950" dirty="0"/>
-          </a:p>
-        </p:txBody>
-      </p:sp>
-      <p:sp>
-        <p:nvSpPr>
-          <p:cNvPr id="38" name="Text 34"/>
-          <p:cNvSpPr txBox="1"/>
-          <p:nvPr/>
-        </p:nvSpPr>
-        <p:spPr>
-          <a:xfrm>
-            <a:off x="749300" y="4673600"/>
-            <a:ext cx="4191000" cy="292100"/>
-          </a:xfrm>
-          <a:prstGeom prst="rect">
-            <a:avLst/>
-          </a:prstGeom>
-          <a:noFill/>
-          <a:ln/>
-        </p:spPr>
-        <p:txBody>
-          <a:bodyPr wrap="square" lIns="0" tIns="0" rIns="0" bIns="0" rtlCol="0" anchor="t"/>
-          <a:lstStyle/>
-          <a:p>
-            <a:pPr indent="0" marL="0">
-              <a:buNone/>
-            </a:pPr>
-            <a:r>
-              <a:rPr lang="en-US" sz="950" b="1" dirty="0">
+              <a:t>To capacity-test and price before any customer artifact</a:t>
+            </a:r>
+            <a:endParaRPr lang="en-US" sz="900" dirty="0"/>
+          </a:p>
+        </p:txBody>
+      </p:sp>
+      <p:sp>
+        <p:nvSpPr>
+          <p:cNvPr id="39" name="Text 35"/>
+          <p:cNvSpPr txBox="1"/>
+          <p:nvPr/>
+        </p:nvSpPr>
+        <p:spPr>
+          <a:xfrm>
+            <a:off x="749300" y="4419600"/>
+            <a:ext cx="4191000" cy="266700"/>
+          </a:xfrm>
+          <a:prstGeom prst="rect">
+            <a:avLst/>
+          </a:prstGeom>
+          <a:noFill/>
+          <a:ln/>
+        </p:spPr>
+        <p:txBody>
+          <a:bodyPr wrap="square" lIns="0" tIns="0" rIns="0" bIns="0" rtlCol="0" anchor="t"/>
+          <a:lstStyle/>
+          <a:p>
+            <a:pPr indent="0" marL="0">
+              <a:buNone/>
+            </a:pPr>
+            <a:r>
+              <a:rPr lang="en-US" sz="900" b="1" dirty="0">
                 <a:solidFill>
                   <a:srgbClr val="15224B"/>
                 </a:solidFill>
@@ -19813,36 +19833,36 @@
               </a:rPr>
               <a:t>Automatum back-to-back turnarounds</a:t>
             </a:r>
-            <a:endParaRPr lang="en-US" sz="950" dirty="0"/>
-          </a:p>
-        </p:txBody>
-      </p:sp>
-      <p:sp>
-        <p:nvSpPr>
-          <p:cNvPr id="39" name="Text 35"/>
-          <p:cNvSpPr txBox="1"/>
-          <p:nvPr/>
-        </p:nvSpPr>
-        <p:spPr>
-          <a:xfrm>
-            <a:off x="5143500" y="4673600"/>
-            <a:ext cx="1905000" cy="292100"/>
-          </a:xfrm>
-          <a:prstGeom prst="rect">
-            <a:avLst/>
-          </a:prstGeom>
-          <a:noFill/>
-          <a:ln/>
-        </p:spPr>
-        <p:txBody>
-          <a:bodyPr wrap="square" lIns="0" tIns="0" rIns="0" bIns="0" rtlCol="0" anchor="t"/>
-          <a:lstStyle/>
-          <a:p>
-            <a:pPr indent="0" marL="0">
-              <a:buNone/>
-            </a:pPr>
-            <a:r>
-              <a:rPr lang="en-US" sz="950" dirty="0">
+            <a:endParaRPr lang="en-US" sz="900" dirty="0"/>
+          </a:p>
+        </p:txBody>
+      </p:sp>
+      <p:sp>
+        <p:nvSpPr>
+          <p:cNvPr id="40" name="Text 36"/>
+          <p:cNvSpPr txBox="1"/>
+          <p:nvPr/>
+        </p:nvSpPr>
+        <p:spPr>
+          <a:xfrm>
+            <a:off x="5143500" y="4419600"/>
+            <a:ext cx="1905000" cy="266700"/>
+          </a:xfrm>
+          <a:prstGeom prst="rect">
+            <a:avLst/>
+          </a:prstGeom>
+          <a:noFill/>
+          <a:ln/>
+        </p:spPr>
+        <p:txBody>
+          <a:bodyPr wrap="square" lIns="0" tIns="0" rIns="0" bIns="0" rtlCol="0" anchor="t"/>
+          <a:lstStyle/>
+          <a:p>
+            <a:pPr indent="0" marL="0">
+              <a:buNone/>
+            </a:pPr>
+            <a:r>
+              <a:rPr lang="en-US" sz="900" dirty="0">
                 <a:solidFill>
                   <a:srgbClr val="5B6378"/>
                 </a:solidFill>
@@ -19852,36 +19872,36 @@
               </a:rPr>
               <a:t>Automatum</a:t>
             </a:r>
-            <a:endParaRPr lang="en-US" sz="950" dirty="0"/>
-          </a:p>
-        </p:txBody>
-      </p:sp>
-      <p:sp>
-        <p:nvSpPr>
-          <p:cNvPr id="40" name="Text 36"/>
-          <p:cNvSpPr txBox="1"/>
-          <p:nvPr/>
-        </p:nvSpPr>
-        <p:spPr>
-          <a:xfrm>
-            <a:off x="7366000" y="4673600"/>
-            <a:ext cx="2895600" cy="292100"/>
-          </a:xfrm>
-          <a:prstGeom prst="rect">
-            <a:avLst/>
-          </a:prstGeom>
-          <a:noFill/>
-          <a:ln/>
-        </p:spPr>
-        <p:txBody>
-          <a:bodyPr wrap="square" lIns="0" tIns="0" rIns="0" bIns="0" rtlCol="0" anchor="t"/>
-          <a:lstStyle/>
-          <a:p>
-            <a:pPr indent="0" marL="0">
-              <a:buNone/>
-            </a:pPr>
-            <a:r>
-              <a:rPr lang="en-US" sz="950" dirty="0">
+            <a:endParaRPr lang="en-US" sz="900" dirty="0"/>
+          </a:p>
+        </p:txBody>
+      </p:sp>
+      <p:sp>
+        <p:nvSpPr>
+          <p:cNvPr id="41" name="Text 37"/>
+          <p:cNvSpPr txBox="1"/>
+          <p:nvPr/>
+        </p:nvSpPr>
+        <p:spPr>
+          <a:xfrm>
+            <a:off x="7366000" y="4419600"/>
+            <a:ext cx="2895600" cy="266700"/>
+          </a:xfrm>
+          <a:prstGeom prst="rect">
+            <a:avLst/>
+          </a:prstGeom>
+          <a:noFill/>
+          <a:ln/>
+        </p:spPr>
+        <p:txBody>
+          <a:bodyPr wrap="square" lIns="0" tIns="0" rIns="0" bIns="0" rtlCol="0" anchor="t"/>
+          <a:lstStyle/>
+          <a:p>
+            <a:pPr indent="0" marL="0">
+              <a:buNone/>
+            </a:pPr>
+            <a:r>
+              <a:rPr lang="en-US" sz="900" dirty="0">
                 <a:solidFill>
                   <a:srgbClr val="5B6378"/>
                 </a:solidFill>
@@ -19889,38 +19909,38 @@
                 <a:ea typeface="Segoe UI Semilight" pitchFamily="34" charset="-122"/>
                 <a:cs typeface="Segoe UI Semilight" pitchFamily="34" charset="-120"/>
               </a:rPr>
-              <a:t>To agree on the call</a:t>
-            </a:r>
-            <a:endParaRPr lang="en-US" sz="950" dirty="0"/>
-          </a:p>
-        </p:txBody>
-      </p:sp>
-      <p:sp>
-        <p:nvSpPr>
-          <p:cNvPr id="41" name="Text 37"/>
-          <p:cNvSpPr txBox="1"/>
-          <p:nvPr/>
-        </p:nvSpPr>
-        <p:spPr>
-          <a:xfrm>
-            <a:off x="749300" y="4965700"/>
-            <a:ext cx="4191000" cy="292100"/>
-          </a:xfrm>
-          <a:prstGeom prst="rect">
-            <a:avLst/>
-          </a:prstGeom>
-          <a:noFill/>
-          <a:ln/>
-        </p:spPr>
-        <p:txBody>
-          <a:bodyPr wrap="square" lIns="0" tIns="0" rIns="0" bIns="0" rtlCol="0" anchor="t"/>
-          <a:lstStyle/>
-          <a:p>
-            <a:pPr indent="0" marL="0">
-              <a:buNone/>
-            </a:pPr>
-            <a:r>
-              <a:rPr lang="en-US" sz="950" b="1" dirty="0">
+              <a:t>Needed before any turnaround is published</a:t>
+            </a:r>
+            <a:endParaRPr lang="en-US" sz="900" dirty="0"/>
+          </a:p>
+        </p:txBody>
+      </p:sp>
+      <p:sp>
+        <p:nvSpPr>
+          <p:cNvPr id="42" name="Text 38"/>
+          <p:cNvSpPr txBox="1"/>
+          <p:nvPr/>
+        </p:nvSpPr>
+        <p:spPr>
+          <a:xfrm>
+            <a:off x="749300" y="4686300"/>
+            <a:ext cx="4191000" cy="266700"/>
+          </a:xfrm>
+          <a:prstGeom prst="rect">
+            <a:avLst/>
+          </a:prstGeom>
+          <a:noFill/>
+          <a:ln/>
+        </p:spPr>
+        <p:txBody>
+          <a:bodyPr wrap="square" lIns="0" tIns="0" rIns="0" bIns="0" rtlCol="0" anchor="t"/>
+          <a:lstStyle/>
+          <a:p>
+            <a:pPr indent="0" marL="0">
+              <a:buNone/>
+            </a:pPr>
+            <a:r>
+              <a:rPr lang="en-US" sz="900" b="1" dirty="0">
                 <a:solidFill>
                   <a:srgbClr val="15224B"/>
                 </a:solidFill>
@@ -19928,38 +19948,155 @@
                 <a:ea typeface="Segoe UI" pitchFamily="34" charset="-122"/>
                 <a:cs typeface="Segoe UI" pitchFamily="34" charset="-120"/>
               </a:rPr>
+              <a:t>CPPO boundary — Operations vs Partner Development</a:t>
+            </a:r>
+            <a:endParaRPr lang="en-US" sz="900" dirty="0"/>
+          </a:p>
+        </p:txBody>
+      </p:sp>
+      <p:sp>
+        <p:nvSpPr>
+          <p:cNvPr id="43" name="Text 39"/>
+          <p:cNvSpPr txBox="1"/>
+          <p:nvPr/>
+        </p:nvSpPr>
+        <p:spPr>
+          <a:xfrm>
+            <a:off x="5143500" y="4686300"/>
+            <a:ext cx="1905000" cy="266700"/>
+          </a:xfrm>
+          <a:prstGeom prst="rect">
+            <a:avLst/>
+          </a:prstGeom>
+          <a:noFill/>
+          <a:ln/>
+        </p:spPr>
+        <p:txBody>
+          <a:bodyPr wrap="square" lIns="0" tIns="0" rIns="0" bIns="0" rtlCol="0" anchor="t"/>
+          <a:lstStyle/>
+          <a:p>
+            <a:pPr indent="0" marL="0">
+              <a:buNone/>
+            </a:pPr>
+            <a:r>
+              <a:rPr lang="en-US" sz="900" dirty="0">
+                <a:solidFill>
+                  <a:srgbClr val="5B6378"/>
+                </a:solidFill>
+                <a:latin typeface="Segoe UI Semilight" pitchFamily="34" charset="0"/>
+                <a:ea typeface="Segoe UI Semilight" pitchFamily="34" charset="-122"/>
+                <a:cs typeface="Segoe UI Semilight" pitchFamily="34" charset="-120"/>
+              </a:rPr>
+              <a:t>OBP + Automatum</a:t>
+            </a:r>
+            <a:endParaRPr lang="en-US" sz="900" dirty="0"/>
+          </a:p>
+        </p:txBody>
+      </p:sp>
+      <p:sp>
+        <p:nvSpPr>
+          <p:cNvPr id="44" name="Text 40"/>
+          <p:cNvSpPr txBox="1"/>
+          <p:nvPr/>
+        </p:nvSpPr>
+        <p:spPr>
+          <a:xfrm>
+            <a:off x="7366000" y="4686300"/>
+            <a:ext cx="2895600" cy="266700"/>
+          </a:xfrm>
+          <a:prstGeom prst="rect">
+            <a:avLst/>
+          </a:prstGeom>
+          <a:noFill/>
+          <a:ln/>
+        </p:spPr>
+        <p:txBody>
+          <a:bodyPr wrap="square" lIns="0" tIns="0" rIns="0" bIns="0" rtlCol="0" anchor="t"/>
+          <a:lstStyle/>
+          <a:p>
+            <a:pPr indent="0" marL="0">
+              <a:buNone/>
+            </a:pPr>
+            <a:r>
+              <a:rPr lang="en-US" sz="900" dirty="0">
+                <a:solidFill>
+                  <a:srgbClr val="5B6378"/>
+                </a:solidFill>
+                <a:latin typeface="Segoe UI Semilight" pitchFamily="34" charset="0"/>
+                <a:ea typeface="Segoe UI Semilight" pitchFamily="34" charset="-122"/>
+                <a:cs typeface="Segoe UI Semilight" pitchFamily="34" charset="-120"/>
+              </a:rPr>
+              <a:t>To confirm</a:t>
+            </a:r>
+            <a:endParaRPr lang="en-US" sz="900" dirty="0"/>
+          </a:p>
+        </p:txBody>
+      </p:sp>
+      <p:sp>
+        <p:nvSpPr>
+          <p:cNvPr id="45" name="Text 41"/>
+          <p:cNvSpPr txBox="1"/>
+          <p:nvPr/>
+        </p:nvSpPr>
+        <p:spPr>
+          <a:xfrm>
+            <a:off x="749300" y="4953000"/>
+            <a:ext cx="4191000" cy="266700"/>
+          </a:xfrm>
+          <a:prstGeom prst="rect">
+            <a:avLst/>
+          </a:prstGeom>
+          <a:noFill/>
+          <a:ln/>
+        </p:spPr>
+        <p:txBody>
+          <a:bodyPr wrap="square" lIns="0" tIns="0" rIns="0" bIns="0" rtlCol="0" anchor="t"/>
+          <a:lstStyle/>
+          <a:p>
+            <a:pPr indent="0" marL="0">
+              <a:buNone/>
+            </a:pPr>
+            <a:r>
+              <a:rPr lang="en-US" sz="900" b="1" dirty="0">
+                <a:solidFill>
+                  <a:srgbClr val="15224B"/>
+                </a:solidFill>
+                <a:latin typeface="Segoe UI" pitchFamily="34" charset="0"/>
+                <a:ea typeface="Segoe UI" pitchFamily="34" charset="-122"/>
+                <a:cs typeface="Segoe UI" pitchFamily="34" charset="-120"/>
+              </a:rPr>
               <a:t>Commercial terms between OBP and Automatum</a:t>
             </a:r>
-            <a:endParaRPr lang="en-US" sz="950" dirty="0"/>
-          </a:p>
-        </p:txBody>
-      </p:sp>
-      <p:sp>
-        <p:nvSpPr>
-          <p:cNvPr id="42" name="Text 38"/>
-          <p:cNvSpPr txBox="1"/>
-          <p:nvPr/>
-        </p:nvSpPr>
-        <p:spPr>
-          <a:xfrm>
-            <a:off x="5143500" y="4965700"/>
-            <a:ext cx="1905000" cy="292100"/>
-          </a:xfrm>
-          <a:prstGeom prst="rect">
-            <a:avLst/>
-          </a:prstGeom>
-          <a:noFill/>
-          <a:ln/>
-        </p:spPr>
-        <p:txBody>
-          <a:bodyPr wrap="square" lIns="0" tIns="0" rIns="0" bIns="0" rtlCol="0" anchor="t"/>
-          <a:lstStyle/>
-          <a:p>
-            <a:pPr indent="0" marL="0">
-              <a:buNone/>
-            </a:pPr>
-            <a:r>
-              <a:rPr lang="en-US" sz="950" dirty="0">
+            <a:endParaRPr lang="en-US" sz="900" dirty="0"/>
+          </a:p>
+        </p:txBody>
+      </p:sp>
+      <p:sp>
+        <p:nvSpPr>
+          <p:cNvPr id="46" name="Text 42"/>
+          <p:cNvSpPr txBox="1"/>
+          <p:nvPr/>
+        </p:nvSpPr>
+        <p:spPr>
+          <a:xfrm>
+            <a:off x="5143500" y="4953000"/>
+            <a:ext cx="1905000" cy="266700"/>
+          </a:xfrm>
+          <a:prstGeom prst="rect">
+            <a:avLst/>
+          </a:prstGeom>
+          <a:noFill/>
+          <a:ln/>
+        </p:spPr>
+        <p:txBody>
+          <a:bodyPr wrap="square" lIns="0" tIns="0" rIns="0" bIns="0" rtlCol="0" anchor="t"/>
+          <a:lstStyle/>
+          <a:p>
+            <a:pPr indent="0" marL="0">
+              <a:buNone/>
+            </a:pPr>
+            <a:r>
+              <a:rPr lang="en-US" sz="900" dirty="0">
                 <a:solidFill>
                   <a:srgbClr val="5B6378"/>
                 </a:solidFill>
@@ -19969,36 +20106,36 @@
               </a:rPr>
               <a:t>OBP + Automatum</a:t>
             </a:r>
-            <a:endParaRPr lang="en-US" sz="950" dirty="0"/>
-          </a:p>
-        </p:txBody>
-      </p:sp>
-      <p:sp>
-        <p:nvSpPr>
-          <p:cNvPr id="43" name="Text 39"/>
-          <p:cNvSpPr txBox="1"/>
-          <p:nvPr/>
-        </p:nvSpPr>
-        <p:spPr>
-          <a:xfrm>
-            <a:off x="7366000" y="4965700"/>
-            <a:ext cx="2895600" cy="292100"/>
-          </a:xfrm>
-          <a:prstGeom prst="rect">
-            <a:avLst/>
-          </a:prstGeom>
-          <a:noFill/>
-          <a:ln/>
-        </p:spPr>
-        <p:txBody>
-          <a:bodyPr wrap="square" lIns="0" tIns="0" rIns="0" bIns="0" rtlCol="0" anchor="t"/>
-          <a:lstStyle/>
-          <a:p>
-            <a:pPr indent="0" marL="0">
-              <a:buNone/>
-            </a:pPr>
-            <a:r>
-              <a:rPr lang="en-US" sz="950" dirty="0">
+            <a:endParaRPr lang="en-US" sz="900" dirty="0"/>
+          </a:p>
+        </p:txBody>
+      </p:sp>
+      <p:sp>
+        <p:nvSpPr>
+          <p:cNvPr id="47" name="Text 43"/>
+          <p:cNvSpPr txBox="1"/>
+          <p:nvPr/>
+        </p:nvSpPr>
+        <p:spPr>
+          <a:xfrm>
+            <a:off x="7366000" y="4953000"/>
+            <a:ext cx="2895600" cy="266700"/>
+          </a:xfrm>
+          <a:prstGeom prst="rect">
+            <a:avLst/>
+          </a:prstGeom>
+          <a:noFill/>
+          <a:ln/>
+        </p:spPr>
+        <p:txBody>
+          <a:bodyPr wrap="square" lIns="0" tIns="0" rIns="0" bIns="0" rtlCol="0" anchor="t"/>
+          <a:lstStyle/>
+          <a:p>
+            <a:pPr indent="0" marL="0">
+              <a:buNone/>
+            </a:pPr>
+            <a:r>
+              <a:rPr lang="en-US" sz="900" dirty="0">
                 <a:solidFill>
                   <a:srgbClr val="5B6378"/>
                 </a:solidFill>
@@ -20008,19 +20145,19 @@
               </a:rPr>
               <a:t>On the agenda for [call date]</a:t>
             </a:r>
-            <a:endParaRPr lang="en-US" sz="950" dirty="0"/>
-          </a:p>
-        </p:txBody>
-      </p:sp>
-      <p:sp>
-        <p:nvSpPr>
-          <p:cNvPr id="44" name="Text 40"/>
-          <p:cNvSpPr txBox="1"/>
-          <p:nvPr/>
-        </p:nvSpPr>
-        <p:spPr>
-          <a:xfrm>
-            <a:off x="749300" y="5334000"/>
+            <a:endParaRPr lang="en-US" sz="900" dirty="0"/>
+          </a:p>
+        </p:txBody>
+      </p:sp>
+      <p:sp>
+        <p:nvSpPr>
+          <p:cNvPr id="48" name="Text 44"/>
+          <p:cNvSpPr txBox="1"/>
+          <p:nvPr/>
+        </p:nvSpPr>
+        <p:spPr>
+          <a:xfrm>
+            <a:off x="749300" y="5308600"/>
             <a:ext cx="10795000" cy="355600"/>
           </a:xfrm>
           <a:prstGeom prst="rect">
@@ -20053,7 +20190,7 @@
       </p:sp>
       <p:sp>
         <p:nvSpPr>
-          <p:cNvPr id="45" name="Shape 41"/>
+          <p:cNvPr id="49" name="Shape 45"/>
           <p:cNvSpPr/>
           <p:nvPr/>
         </p:nvSpPr>
@@ -20075,7 +20212,7 @@
       </p:sp>
       <p:sp>
         <p:nvSpPr>
-          <p:cNvPr id="46" name="Text 42"/>
+          <p:cNvPr id="50" name="Text 46"/>
           <p:cNvSpPr txBox="1"/>
           <p:nvPr/>
         </p:nvSpPr>
@@ -20120,7 +20257,7 @@
                 <a:ea typeface="Segoe UI Semilight" pitchFamily="34" charset="-122"/>
                 <a:cs typeface="Segoe UI Semilight" pitchFamily="34" charset="-120"/>
               </a:rPr>
-              <a:t>    Approve the two-wave sequence, confirm the lead partner of record, agree the back-to-back turnarounds, and calendar wave one’s Milestone 1 for [date].</a:t>
+              <a:t>    Approve the two-wave sequence, confirm the lead partner of record, agree the back-to-back turnarounds and the CPPO boundary, and calendar wave one’s Milestone 1 for [date].</a:t>
             </a:r>
             <a:endParaRPr lang="en-US" sz="1050" dirty="0"/>
           </a:p>
@@ -20761,7 +20898,7 @@
                 <a:ea typeface="Segoe UI" pitchFamily="34" charset="-122"/>
                 <a:cs typeface="Segoe UI" pitchFamily="34" charset="-120"/>
               </a:rPr>
-              <a:t>THE RENAME CASCADE — NOBODY HAS PRICED THIS</a:t>
+              <a:t>THE RENAME CASCADE — PRICE IT BEFORE APPROVING</a:t>
             </a:r>
             <a:endParaRPr lang="en-US" sz="800" dirty="0"/>
           </a:p>
@@ -23365,7 +23502,7 @@
                 <a:ea typeface="Segoe UI Semilight" pitchFamily="34" charset="-122"/>
                 <a:cs typeface="Segoe UI Semilight" pitchFamily="34" charset="-120"/>
               </a:rPr>
-              <a:t>[none named in the deck — confirm]</a:t>
+              <a:t>[none named — to confirm]</a:t>
             </a:r>
             <a:endParaRPr lang="en-US" sz="850" dirty="0"/>
           </a:p>
@@ -23404,7 +23541,7 @@
                 <a:ea typeface="Segoe UI Semilight" pitchFamily="34" charset="-122"/>
                 <a:cs typeface="Segoe UI Semilight" pitchFamily="34" charset="-120"/>
               </a:rPr>
-              <a:t>[none named in the deck — confirm]</a:t>
+              <a:t>[none named — to confirm]</a:t>
             </a:r>
             <a:endParaRPr lang="en-US" sz="850" dirty="0"/>
           </a:p>

</xml_diff>